<commit_message>
Up to the demo OK now
</commit_message>
<xml_diff>
--- a/docs/instructor/lab-2b-guardrails.pptx
+++ b/docs/instructor/lab-2b-guardrails.pptx
@@ -1156,7 +1156,7 @@
           <a:lstStyle/>
           <a:p>
             <a:r>
-              <a:t>Three minutes, no hands-on. Why it is here: their real world is SQL Server and stored procedures, and the pattern they just built on a JSON file needs to visibly transfer. The false-positive row is the most valuable one — it is the PARTLY tag from the severity slide, in the wild. ~3 min.</a:t>
+              <a:t>Three minutes, no hands-on. Why it is here: their real world is SQL Server and stored procedures, and the pattern they just built on a JSON file needs to visibly transfer. The false-positive row is the most valuable one — it is the PARTLY tag from the severity slide, in the wild. The takeaway card now carries a SECOND worked example ("all backends must use SQLite" — ADR for the why, NFR for the must + CI dependency scan, deny rule on npm install pg*), whose org-wide reach also previews the hand-off two slides from now. Point at it; do not teach it. ~3 min.</a:t>
             </a:r>
           </a:p>
         </p:txBody>
@@ -1296,7 +1296,7 @@
           <a:lstStyle/>
           <a:p>
             <a:r>
-              <a:t>[CALIBRATED from Lab 1.b, 2026-08-12: agenda held · checkpoint gates worked · keep as built] The slack is real this time; protect it for verification, which is the step people skip. Prereq check right now, out loud: Lab 2.a done (ADR + NFR wired in), and the Hooks lesson done — anyone missing either pairs up for the build sections and catches up async per the handout. Assessment disclosure: same rubric, and today's hook or gate is also the Framework Practitioner artifact. ~2 min.</a:t>
+              <a:t>[CALIBRATED from Lab 1.b, 2026-08-12: agenda held · checkpoint gates worked · keep as built] The blocks sum to ~103 — the slack is deliberate; protect it for verification, which is the step people skip. Prereq check right now, out loud: Lab 2.a done (ADR + NFR wired in), and the Hooks lesson done — anyone missing either pairs up for the build sections and catches up async per the handout. Assessment disclosure: same rubric, and today's hook or gate is also the Framework Practitioner artifact. ~2 min.</a:t>
             </a:r>
           </a:p>
         </p:txBody>
@@ -13008,48 +13008,6 @@
                 <a:latin typeface="Arial"/>
               </a:rPr>
               <a:t>The sixth artifact; reflect; capture</a:t>
-            </a:r>
-          </a:p>
-        </p:txBody>
-      </p:sp>
-      <p:sp>
-        <p:nvSpPr>
-          <p:cNvPr id="36" name="TextBox 35"/>
-          <p:cNvSpPr txBox="1"/>
-          <p:nvPr/>
-        </p:nvSpPr>
-        <p:spPr>
-          <a:xfrm>
-            <a:off x="548640" y="4992624"/>
-            <a:ext cx="7863840" cy="365760"/>
-          </a:xfrm>
-          <a:prstGeom prst="rect">
-            <a:avLst/>
-          </a:prstGeom>
-          <a:noFill/>
-        </p:spPr>
-        <p:txBody>
-          <a:bodyPr wrap="square" anchor="t" lIns="0" rIns="0" tIns="0" bIns="0">
-            <a:spAutoFit/>
-          </a:bodyPr>
-          <a:lstStyle/>
-          <a:p>
-            <a:pPr algn="l">
-              <a:lnSpc>
-                <a:spcPct val="120000"/>
-              </a:lnSpc>
-              <a:spcAft>
-                <a:spcPts val="400"/>
-              </a:spcAft>
-            </a:pPr>
-            <a:r>
-              <a:rPr sz="1000" b="0">
-                <a:solidFill>
-                  <a:srgbClr val="999999"/>
-                </a:solidFill>
-                <a:latin typeface="Arial"/>
-              </a:rPr>
-              <a:t>Sums to ~103 — the slack is deliberate, and it gets spent on the verify steps.</a:t>
             </a:r>
           </a:p>
         </p:txBody>

</xml_diff>